<commit_message>
fix(history): dual-persist generated plans to LocalStorage + Atlas & update PPT content
</commit_message>
<xml_diff>
--- a/presentation/Spot-Undoo_Presentation.pptx
+++ b/presentation/Spot-Undoo_Presentation.pptx
@@ -14417,16 +14417,7 @@
               <a:buNone/>
             </a:pPr>
             <a:r>
-              <a:rPr b="1" i="0" lang="en-US" sz="1125" u="none" cap="none" strike="noStrike">
-                <a:solidFill>
-                  <a:srgbClr val="0F172A"/>
-                </a:solidFill>
-                <a:latin typeface="Plus Jakarta Sans"/>
-                <a:ea typeface="Plus Jakarta Sans"/>
-                <a:cs typeface="Plus Jakarta Sans"/>
-                <a:sym typeface="Plus Jakarta Sans"/>
-              </a:rPr>
-              <a:t>Live Shoranur Demo Dataset</a:t>
+              <a:t>Live Kerala Multi-Hub Dataset</a:t>
             </a:r>
             <a:endParaRPr/>
           </a:p>
@@ -16133,16 +16124,7 @@
               <a:buNone/>
             </a:pPr>
             <a:r>
-              <a:rPr b="1" lang="en-US" sz="1050">
-                <a:solidFill>
-                  <a:srgbClr val="0F172A"/>
-                </a:solidFill>
-                <a:latin typeface="Plus Jakarta Sans"/>
-                <a:ea typeface="Plus Jakarta Sans"/>
-                <a:cs typeface="Plus Jakarta Sans"/>
-                <a:sym typeface="Plus Jakarta Sans"/>
-              </a:rPr>
-              <a:t>POWERED BY LOCAL QWEN3 4B </a:t>
+              <a:t>POWERED BY LOCAL QWEN 2.5:3B </a:t>
             </a:r>
             <a:endParaRPr/>
           </a:p>
@@ -18507,16 +18489,7 @@
               <a:buNone/>
             </a:pPr>
             <a:r>
-              <a:rPr b="1" i="0" lang="en-US" sz="900" u="none" cap="none" strike="noStrike">
-                <a:solidFill>
-                  <a:srgbClr val="F8FAFC"/>
-                </a:solidFill>
-                <a:latin typeface="Plus Jakarta Sans"/>
-                <a:ea typeface="Plus Jakarta Sans"/>
-                <a:cs typeface="Plus Jakarta Sans"/>
-                <a:sym typeface="Plus Jakarta Sans"/>
-              </a:rPr>
-              <a:t>ITINERARY MAP</a:t>
+              <a:t>NEO-BRUTALIST ADVENTURE TRAIL</a:t>
             </a:r>
             <a:endParaRPr/>
           </a:p>
@@ -18560,16 +18533,7 @@
               <a:buNone/>
             </a:pPr>
             <a:r>
-              <a:rPr b="1" i="0" lang="en-US" sz="2700" u="none" cap="none" strike="noStrike">
-                <a:solidFill>
-                  <a:srgbClr val="000000"/>
-                </a:solidFill>
-                <a:latin typeface="Plus Jakarta Sans"/>
-                <a:ea typeface="Plus Jakarta Sans"/>
-                <a:cs typeface="Plus Jakarta Sans"/>
-                <a:sym typeface="Plus Jakarta Sans"/>
-              </a:rPr>
-              <a:t>Adventure Trail &amp; Step-by-Step Route</a:t>
+              <a:t>Adventure Trail with Safe Return &amp; Dot Anchor</a:t>
             </a:r>
             <a:endParaRPr/>
           </a:p>
@@ -20918,16 +20882,7 @@
               <a:buNone/>
             </a:pPr>
             <a:r>
-              <a:rPr b="1" i="0" lang="en-US" sz="2700" u="none" cap="none" strike="noStrike">
-                <a:solidFill>
-                  <a:srgbClr val="000000"/>
-                </a:solidFill>
-                <a:latin typeface="Plus Jakarta Sans"/>
-                <a:ea typeface="Plus Jakarta Sans"/>
-                <a:cs typeface="Plus Jakarta Sans"/>
-                <a:sym typeface="Plus Jakarta Sans"/>
-              </a:rPr>
-              <a:t>Add Spot: Community Vision Contribution</a:t>
+              <a:t>Add Spot: Community Contributions &amp; Dup Guard</a:t>
             </a:r>
             <a:endParaRPr/>
           </a:p>
@@ -23145,16 +23100,7 @@
               <a:buNone/>
             </a:pPr>
             <a:r>
-              <a:rPr b="1" i="0" lang="en-US" sz="1500" u="none" cap="none" strike="noStrike">
-                <a:solidFill>
-                  <a:srgbClr val="0F172A"/>
-                </a:solidFill>
-                <a:latin typeface="Plus Jakarta Sans"/>
-                <a:ea typeface="Plus Jakarta Sans"/>
-                <a:cs typeface="Plus Jakarta Sans"/>
-                <a:sym typeface="Plus Jakarta Sans"/>
-              </a:rPr>
-              <a:t>Deterministic Hard Filter</a:t>
+              <a:t>Deterministic Hard Filter (Pool Expanded to 20)</a:t>
             </a:r>
             <a:endParaRPr/>
           </a:p>
@@ -24568,16 +24514,7 @@
               <a:buNone/>
             </a:pPr>
             <a:r>
-              <a:rPr b="1" i="0" lang="en-US" sz="1050" u="none" cap="none" strike="noStrike">
-                <a:solidFill>
-                  <a:srgbClr val="0F172A"/>
-                </a:solidFill>
-                <a:latin typeface="Plus Jakarta Sans"/>
-                <a:ea typeface="Plus Jakarta Sans"/>
-                <a:cs typeface="Plus Jakarta Sans"/>
-                <a:sym typeface="Plus Jakarta Sans"/>
-              </a:rPr>
-              <a:t>Offline-First Local Store</a:t>
+              <a:t>Hybrid Local + Atlas Persistence</a:t>
             </a:r>
             <a:endParaRPr/>
           </a:p>
@@ -26689,16 +26626,7 @@
               <a:buNone/>
             </a:pPr>
             <a:r>
-              <a:rPr b="1" i="0" lang="en-US" sz="1050" u="none" cap="none" strike="noStrike">
-                <a:solidFill>
-                  <a:srgbClr val="475569"/>
-                </a:solidFill>
-                <a:latin typeface="Plus Jakarta Sans"/>
-                <a:ea typeface="Plus Jakarta Sans"/>
-                <a:cs typeface="Plus Jakarta Sans"/>
-                <a:sym typeface="Plus Jakarta Sans"/>
-              </a:rPr>
-              <a:t>Shared Global Community Feed</a:t>
+              <a:t>Native Android APK &amp; PWA Offline Package</a:t>
             </a:r>
             <a:endParaRPr/>
           </a:p>
@@ -26739,16 +26667,7 @@
               <a:buNone/>
             </a:pPr>
             <a:r>
-              <a:rPr b="1" i="0" lang="en-US" sz="1050" u="none" cap="none" strike="noStrike">
-                <a:solidFill>
-                  <a:srgbClr val="475569"/>
-                </a:solidFill>
-                <a:latin typeface="Plus Jakarta Sans"/>
-                <a:ea typeface="Plus Jakarta Sans"/>
-                <a:cs typeface="Plus Jakarta Sans"/>
-                <a:sym typeface="Plus Jakarta Sans"/>
-              </a:rPr>
-              <a:t>Cross-Device Profile &amp; Saved Sync</a:t>
+              <a:t>Geospatial Duplicate Protection (±0.00001°)</a:t>
             </a:r>
             <a:endParaRPr/>
           </a:p>
@@ -26839,16 +26758,7 @@
               <a:buNone/>
             </a:pPr>
             <a:r>
-              <a:rPr b="1" i="0" lang="en-US" sz="1050" u="none" cap="none" strike="noStrike">
-                <a:solidFill>
-                  <a:srgbClr val="475569"/>
-                </a:solidFill>
-                <a:latin typeface="Plus Jakarta Sans"/>
-                <a:ea typeface="Plus Jakarta Sans"/>
-                <a:cs typeface="Plus Jakarta Sans"/>
-                <a:sym typeface="Plus Jakarta Sans"/>
-              </a:rPr>
-              <a:t>Interactive Itinerary Step Editing</a:t>
+              <a:t>Dual-Strategy High-Accuracy Auto-GPS</a:t>
             </a:r>
             <a:endParaRPr/>
           </a:p>

</xml_diff>